<commit_message>
Add Medium focus slide: 30-40 tm (69% of value) with brace chart, rationale and feature head-to-head
Co-Authored-By: Claude Opus 5.5 <noreply@anthropic.com>
Claude-Session: https://claude.ai/code/session_01Cx9kswyecF7JAB1Rr5vVcV
</commit_message>
<xml_diff>
--- a/nedp_deck/STP_Medium_Heavy_TopValue.pptx
+++ b/nedp_deck/STP_Medium_Heavy_TopValue.pptx
@@ -3382,7 +3382,7 @@
                 </a:solidFill>
                 <a:latin typeface="Arial"/>
               </a:rPr>
-              <a:t>Medium class split into 4 tm tiers. 30–40 tm holds 68% of Medium value (143 of 218 units).</a:t>
+              <a:t>Medium class split into 4 tm tiers. 30–40 tm holds 69% of Medium value (142 of 214 units).</a:t>
             </a:r>
           </a:p>
         </p:txBody>
@@ -3614,7 +3614,7 @@
                 </a:solidFill>
                 <a:latin typeface="Arial"/>
               </a:rPr>
-              <a:t>Ferrari is 14%–25% cheaper than the value leader at 25–40 tm (86% of Medium value). At 40–45 tm, 746 A4 is 48% above SPK42502.</a:t>
+              <a:t>Ferrari is 14%–25% cheaper than the value leader at 25–40 tm (88% of Medium value). At 40–45 tm, 746 A4 is 48% above SPK42502.</a:t>
             </a:r>
           </a:p>
         </p:txBody>
@@ -4205,7 +4205,7 @@
                           </a:solidFill>
                           <a:latin typeface="Arial"/>
                         </a:rPr>
-                        <a:t>18%</a:t>
+                        <a:t>19%</a:t>
                       </a:r>
                     </a:p>
                   </a:txBody>
@@ -4437,7 +4437,7 @@
                           </a:solidFill>
                           <a:latin typeface="Arial"/>
                         </a:rPr>
-                        <a:t>77</a:t>
+                        <a:t>76</a:t>
                       </a:r>
                     </a:p>
                   </a:txBody>
@@ -4552,7 +4552,7 @@
                           </a:solidFill>
                           <a:latin typeface="Arial"/>
                         </a:rPr>
-                        <a:t>36%</a:t>
+                        <a:t>37%</a:t>
                       </a:r>
                     </a:p>
                   </a:txBody>
@@ -4947,7 +4947,7 @@
                           </a:solidFill>
                           <a:latin typeface="Arial"/>
                         </a:rPr>
-                        <a:t>26</a:t>
+                        <a:t>23</a:t>
                       </a:r>
                     </a:p>
                   </a:txBody>
@@ -4970,7 +4970,7 @@
                           </a:solidFill>
                           <a:latin typeface="Arial"/>
                         </a:rPr>
-                        <a:t>14%</a:t>
+                        <a:t>12%</a:t>
                       </a:r>
                     </a:p>
                   </a:txBody>
@@ -5062,7 +5062,7 @@
                           </a:solidFill>
                           <a:latin typeface="Arial"/>
                         </a:rPr>
-                        <a:t>68%</a:t>
+                        <a:t>81%</a:t>
                       </a:r>
                     </a:p>
                   </a:txBody>
@@ -5620,7 +5620,7 @@
                 </a:solidFill>
                 <a:latin typeface="Arial"/>
               </a:rPr>
-              <a:t>Heavy class split into 7 tm tiers. 45–55 tm holds 83% of Heavy value (63 of 75 units); tiers above 55 tm have 1–4 units each.</a:t>
+              <a:t>Heavy class split into 6 tm tiers. 45–55 tm holds 87% of Heavy value (59 of 68 units); tiers above 55 tm have 1–4 units each.</a:t>
             </a:r>
           </a:p>
         </p:txBody>
@@ -5736,7 +5736,7 @@
                 </a:solidFill>
                 <a:latin typeface="Arial"/>
               </a:rPr>
-              <a:t>Top 1 model by value: Amco Veba V950 at 45–50 tm (66% of tier value) and Palfinger PK 53002 at 50–55 tm (95%).</a:t>
+              <a:t>Top 1 model by value: Amco Veba V950 at 45–50 tm (77% of tier value) and Palfinger PK 53002 at 50–55 tm (95%).</a:t>
             </a:r>
           </a:p>
         </p:txBody>
@@ -5852,7 +5852,7 @@
                 </a:solidFill>
                 <a:latin typeface="Arial"/>
               </a:rPr>
-              <a:t>FBR450R A4 is 32% cheaper than V950 (28% of Heavy value). 9601CR A8 is 85% above PK 53002 at 50–55 tm (55%); no Ferrari model above 74 tm.</a:t>
+              <a:t>FBR450R A4 is 32% cheaper than V950 (26% of Heavy value). 9601CR A8 is 85% above PK 53002 at 50–55 tm (60%); no Ferrari model above 74 tm.</a:t>
             </a:r>
           </a:p>
         </p:txBody>
@@ -5867,7 +5867,7 @@
         </p:nvGraphicFramePr>
         <p:xfrm>
           <a:off x="533400" y="2686050"/>
-          <a:ext cx="11125200" cy="3190875"/>
+          <a:ext cx="11125200" cy="3181350"/>
         </p:xfrm>
         <a:graphic>
           <a:graphicData uri="http://schemas.openxmlformats.org/drawingml/2006/table">
@@ -6383,7 +6383,7 @@
                   </a:tcPr>
                 </a:tc>
               </a:tr>
-              <a:tr h="352425">
+              <a:tr h="409575">
                 <a:tc>
                   <a:txBody>
                     <a:bodyPr/>
@@ -6420,7 +6420,7 @@
                           </a:solidFill>
                           <a:latin typeface="Arial"/>
                         </a:rPr>
-                        <a:t>23</a:t>
+                        <a:t>19</a:t>
                       </a:r>
                     </a:p>
                   </a:txBody>
@@ -6443,7 +6443,7 @@
                           </a:solidFill>
                           <a:latin typeface="Arial"/>
                         </a:rPr>
-                        <a:t>28%</a:t>
+                        <a:t>26%</a:t>
                       </a:r>
                     </a:p>
                   </a:txBody>
@@ -6535,7 +6535,7 @@
                           </a:solidFill>
                           <a:latin typeface="Arial"/>
                         </a:rPr>
-                        <a:t>66%</a:t>
+                        <a:t>77%</a:t>
                       </a:r>
                     </a:p>
                   </a:txBody>
@@ -6638,7 +6638,7 @@
                   </a:tcPr>
                 </a:tc>
               </a:tr>
-              <a:tr h="352425">
+              <a:tr h="409575">
                 <a:tc>
                   <a:txBody>
                     <a:bodyPr/>
@@ -6698,7 +6698,7 @@
                           </a:solidFill>
                           <a:latin typeface="Arial"/>
                         </a:rPr>
-                        <a:t>55%</a:t>
+                        <a:t>60%</a:t>
                       </a:r>
                     </a:p>
                   </a:txBody>
@@ -6893,7 +6893,7 @@
                   </a:tcPr>
                 </a:tc>
               </a:tr>
-              <a:tr h="352425">
+              <a:tr h="409575">
                 <a:tc>
                   <a:txBody>
                     <a:bodyPr/>
@@ -6907,7 +6907,7 @@
                           </a:solidFill>
                           <a:latin typeface="Arial"/>
                         </a:rPr>
-                        <a:t>55 – 60</a:t>
+                        <a:t>60 – 65</a:t>
                       </a:r>
                     </a:p>
                   </a:txBody>
@@ -6930,7 +6930,7 @@
                           </a:solidFill>
                           <a:latin typeface="Arial"/>
                         </a:rPr>
-                        <a:t>3</a:t>
+                        <a:t>2</a:t>
                       </a:r>
                     </a:p>
                   </a:txBody>
@@ -6953,6 +6953,261 @@
                           </a:solidFill>
                           <a:latin typeface="Arial"/>
                         </a:rPr>
+                        <a:t>2%</a:t>
+                      </a:r>
+                    </a:p>
+                  </a:txBody>
+                  <a:tcPr anchor="ctr" marL="38100" marR="38100" marT="9525" marB="9525">
+                    <a:solidFill>
+                      <a:srgbClr val="FFFFFF"/>
+                    </a:solidFill>
+                  </a:tcPr>
+                </a:tc>
+                <a:tc>
+                  <a:txBody>
+                    <a:bodyPr/>
+                    <a:lstStyle/>
+                    <a:p>
+                      <a:pPr algn="ctr"/>
+                      <a:r>
+                        <a:rPr sz="1100" b="1">
+                          <a:solidFill>
+                            <a:srgbClr val="11181C"/>
+                          </a:solidFill>
+                          <a:latin typeface="Arial"/>
+                        </a:rPr>
+                        <a:t>Sany Palfinger</a:t>
+                      </a:r>
+                    </a:p>
+                  </a:txBody>
+                  <a:tcPr anchor="ctr" marL="38100" marR="38100" marT="9525" marB="9525">
+                    <a:solidFill>
+                      <a:srgbClr val="FFFFFF"/>
+                    </a:solidFill>
+                  </a:tcPr>
+                </a:tc>
+                <a:tc>
+                  <a:txBody>
+                    <a:bodyPr/>
+                    <a:lstStyle/>
+                    <a:p>
+                      <a:pPr algn="ctr"/>
+                      <a:r>
+                        <a:rPr sz="1100" b="0">
+                          <a:solidFill>
+                            <a:srgbClr val="11181C"/>
+                          </a:solidFill>
+                          <a:latin typeface="Arial"/>
+                        </a:rPr>
+                        <a:t>SPK61502</a:t>
+                      </a:r>
+                    </a:p>
+                  </a:txBody>
+                  <a:tcPr anchor="ctr" marL="38100" marR="38100" marT="9525" marB="9525">
+                    <a:solidFill>
+                      <a:srgbClr val="FFFFFF"/>
+                    </a:solidFill>
+                  </a:tcPr>
+                </a:tc>
+                <a:tc>
+                  <a:txBody>
+                    <a:bodyPr/>
+                    <a:lstStyle/>
+                    <a:p>
+                      <a:pPr algn="ctr"/>
+                      <a:r>
+                        <a:rPr sz="1100" b="0">
+                          <a:solidFill>
+                            <a:srgbClr val="11181C"/>
+                          </a:solidFill>
+                          <a:latin typeface="Arial"/>
+                        </a:rPr>
+                        <a:t>1</a:t>
+                      </a:r>
+                    </a:p>
+                  </a:txBody>
+                  <a:tcPr anchor="ctr" marL="38100" marR="38100" marT="9525" marB="9525">
+                    <a:solidFill>
+                      <a:srgbClr val="FFFFFF"/>
+                    </a:solidFill>
+                  </a:tcPr>
+                </a:tc>
+                <a:tc>
+                  <a:txBody>
+                    <a:bodyPr/>
+                    <a:lstStyle/>
+                    <a:p>
+                      <a:pPr algn="ctr"/>
+                      <a:r>
+                        <a:rPr sz="1100" b="0">
+                          <a:solidFill>
+                            <a:srgbClr val="11181C"/>
+                          </a:solidFill>
+                          <a:latin typeface="Arial"/>
+                        </a:rPr>
+                        <a:t>57%</a:t>
+                      </a:r>
+                    </a:p>
+                  </a:txBody>
+                  <a:tcPr anchor="ctr" marL="38100" marR="38100" marT="9525" marB="9525">
+                    <a:solidFill>
+                      <a:srgbClr val="FFFFFF"/>
+                    </a:solidFill>
+                  </a:tcPr>
+                </a:tc>
+                <a:tc>
+                  <a:txBody>
+                    <a:bodyPr/>
+                    <a:lstStyle/>
+                    <a:p>
+                      <a:pPr algn="ctr"/>
+                      <a:r>
+                        <a:rPr sz="1100" b="0">
+                          <a:solidFill>
+                            <a:srgbClr val="11181C"/>
+                          </a:solidFill>
+                          <a:latin typeface="Arial"/>
+                        </a:rPr>
+                        <a:t>Rp 1.400.000.000</a:t>
+                      </a:r>
+                    </a:p>
+                  </a:txBody>
+                  <a:tcPr anchor="ctr" marL="38100" marR="38100" marT="9525" marB="9525">
+                    <a:solidFill>
+                      <a:srgbClr val="FFFFFF"/>
+                    </a:solidFill>
+                  </a:tcPr>
+                </a:tc>
+                <a:tc>
+                  <a:txBody>
+                    <a:bodyPr/>
+                    <a:lstStyle/>
+                    <a:p>
+                      <a:pPr algn="ctr"/>
+                      <a:r>
+                        <a:rPr sz="1100" b="1">
+                          <a:solidFill>
+                            <a:srgbClr val="11181C"/>
+                          </a:solidFill>
+                          <a:latin typeface="Arial"/>
+                        </a:rPr>
+                        <a:t>Ferrari</a:t>
+                      </a:r>
+                    </a:p>
+                  </a:txBody>
+                  <a:tcPr anchor="ctr" marL="38100" marR="38100" marT="9525" marB="9525">
+                    <a:solidFill>
+                      <a:srgbClr val="FEEBEC"/>
+                    </a:solidFill>
+                  </a:tcPr>
+                </a:tc>
+                <a:tc>
+                  <a:txBody>
+                    <a:bodyPr/>
+                    <a:lstStyle/>
+                    <a:p>
+                      <a:pPr algn="ctr"/>
+                      <a:r>
+                        <a:rPr sz="1100" b="0">
+                          <a:solidFill>
+                            <a:srgbClr val="11181C"/>
+                          </a:solidFill>
+                          <a:latin typeface="Arial"/>
+                        </a:rPr>
+                        <a:t>9661C</a:t>
+                      </a:r>
+                    </a:p>
+                  </a:txBody>
+                  <a:tcPr anchor="ctr" marL="38100" marR="38100" marT="9525" marB="9525">
+                    <a:solidFill>
+                      <a:srgbClr val="FEEBEC"/>
+                    </a:solidFill>
+                  </a:tcPr>
+                </a:tc>
+                <a:tc>
+                  <a:txBody>
+                    <a:bodyPr/>
+                    <a:lstStyle/>
+                    <a:p>
+                      <a:pPr algn="ctr"/>
+                      <a:r>
+                        <a:rPr sz="1100" b="0">
+                          <a:solidFill>
+                            <a:srgbClr val="11181C"/>
+                          </a:solidFill>
+                          <a:latin typeface="Arial"/>
+                        </a:rPr>
+                        <a:t>Rp 3.970.000.000  (+184%)</a:t>
+                      </a:r>
+                    </a:p>
+                  </a:txBody>
+                  <a:tcPr anchor="ctr" marL="38100" marR="38100" marT="9525" marB="9525">
+                    <a:solidFill>
+                      <a:srgbClr val="FEEBEC"/>
+                    </a:solidFill>
+                  </a:tcPr>
+                </a:tc>
+              </a:tr>
+              <a:tr h="409575">
+                <a:tc>
+                  <a:txBody>
+                    <a:bodyPr/>
+                    <a:lstStyle/>
+                    <a:p>
+                      <a:pPr algn="ctr"/>
+                      <a:r>
+                        <a:rPr sz="1100" b="1">
+                          <a:solidFill>
+                            <a:srgbClr val="11181C"/>
+                          </a:solidFill>
+                          <a:latin typeface="Arial"/>
+                        </a:rPr>
+                        <a:t>70 – 75</a:t>
+                      </a:r>
+                    </a:p>
+                  </a:txBody>
+                  <a:tcPr anchor="ctr" marL="38100" marR="38100" marT="9525" marB="9525">
+                    <a:solidFill>
+                      <a:srgbClr val="FFFFFF"/>
+                    </a:solidFill>
+                  </a:tcPr>
+                </a:tc>
+                <a:tc>
+                  <a:txBody>
+                    <a:bodyPr/>
+                    <a:lstStyle/>
+                    <a:p>
+                      <a:pPr algn="ctr"/>
+                      <a:r>
+                        <a:rPr sz="1100" b="0">
+                          <a:solidFill>
+                            <a:srgbClr val="11181C"/>
+                          </a:solidFill>
+                          <a:latin typeface="Arial"/>
+                        </a:rPr>
+                        <a:t>2</a:t>
+                      </a:r>
+                    </a:p>
+                  </a:txBody>
+                  <a:tcPr anchor="ctr" marL="38100" marR="38100" marT="9525" marB="9525">
+                    <a:solidFill>
+                      <a:srgbClr val="FFFFFF"/>
+                    </a:solidFill>
+                  </a:tcPr>
+                </a:tc>
+                <a:tc>
+                  <a:txBody>
+                    <a:bodyPr/>
+                    <a:lstStyle/>
+                    <a:p>
+                      <a:pPr algn="ctr"/>
+                      <a:r>
+                        <a:rPr sz="1100" b="0">
+                          <a:solidFill>
+                            <a:srgbClr val="11181C"/>
+                          </a:solidFill>
+                          <a:latin typeface="Arial"/>
+                        </a:rPr>
                         <a:t>4%</a:t>
                       </a:r>
                     </a:p>
@@ -6976,7 +7231,7 @@
                           </a:solidFill>
                           <a:latin typeface="Arial"/>
                         </a:rPr>
-                        <a:t>Hyva</a:t>
+                        <a:t>Palfinger</a:t>
                       </a:r>
                     </a:p>
                   </a:txBody>
@@ -6999,7 +7254,7 @@
                           </a:solidFill>
                           <a:latin typeface="Arial"/>
                         </a:rPr>
-                        <a:t>HB660</a:t>
+                        <a:t>PK 76002</a:t>
                       </a:r>
                     </a:p>
                   </a:txBody>
@@ -7045,7 +7300,7 @@
                           </a:solidFill>
                           <a:latin typeface="Arial"/>
                         </a:rPr>
-                        <a:t>68%</a:t>
+                        <a:t>100%</a:t>
                       </a:r>
                     </a:p>
                   </a:txBody>
@@ -7068,7 +7323,7 @@
                           </a:solidFill>
                           <a:latin typeface="Arial"/>
                         </a:rPr>
-                        <a:t>Rp 1.980.000.000</a:t>
+                        <a:t>Rp 2.290.000.000</a:t>
                       </a:r>
                     </a:p>
                   </a:txBody>
@@ -7097,7 +7352,7 @@
                   </a:txBody>
                   <a:tcPr anchor="ctr" marL="38100" marR="38100" marT="9525" marB="9525">
                     <a:solidFill>
-                      <a:srgbClr val="FFF7C2"/>
+                      <a:srgbClr val="FEEBEC"/>
                     </a:solidFill>
                   </a:tcPr>
                 </a:tc>
@@ -7114,13 +7369,13 @@
                           </a:solidFill>
                           <a:latin typeface="Arial"/>
                         </a:rPr>
-                        <a:t>FBR660R A4</a:t>
-                      </a:r>
-                    </a:p>
-                  </a:txBody>
-                  <a:tcPr anchor="ctr" marL="38100" marR="38100" marT="9525" marB="9525">
-                    <a:solidFill>
-                      <a:srgbClr val="FFF7C2"/>
+                        <a:t>990R</a:t>
+                      </a:r>
+                    </a:p>
+                  </a:txBody>
+                  <a:tcPr anchor="ctr" marL="38100" marR="38100" marT="9525" marB="9525">
+                    <a:solidFill>
+                      <a:srgbClr val="FEEBEC"/>
                     </a:solidFill>
                   </a:tcPr>
                 </a:tc>
@@ -7137,18 +7392,18 @@
                           </a:solidFill>
                           <a:latin typeface="Arial"/>
                         </a:rPr>
-                        <a:t>Rp 2.030.000.000  (+3%)</a:t>
-                      </a:r>
-                    </a:p>
-                  </a:txBody>
-                  <a:tcPr anchor="ctr" marL="38100" marR="38100" marT="9525" marB="9525">
-                    <a:solidFill>
-                      <a:srgbClr val="FFF7C2"/>
+                        <a:t>Rp 4.110.000.000  (+79%)</a:t>
+                      </a:r>
+                    </a:p>
+                  </a:txBody>
+                  <a:tcPr anchor="ctr" marL="38100" marR="38100" marT="9525" marB="9525">
+                    <a:solidFill>
+                      <a:srgbClr val="FEEBEC"/>
                     </a:solidFill>
                   </a:tcPr>
                 </a:tc>
               </a:tr>
-              <a:tr h="352425">
+              <a:tr h="409575">
                 <a:tc>
                   <a:txBody>
                     <a:bodyPr/>
@@ -7162,7 +7417,7 @@
                           </a:solidFill>
                           <a:latin typeface="Arial"/>
                         </a:rPr>
-                        <a:t>60 – 65</a:t>
+                        <a:t>80 – 85</a:t>
                       </a:r>
                     </a:p>
                   </a:txBody>
@@ -7185,7 +7440,7 @@
                           </a:solidFill>
                           <a:latin typeface="Arial"/>
                         </a:rPr>
-                        <a:t>2</a:t>
+                        <a:t>1</a:t>
                       </a:r>
                     </a:p>
                   </a:txBody>
@@ -7231,7 +7486,7 @@
                           </a:solidFill>
                           <a:latin typeface="Arial"/>
                         </a:rPr>
-                        <a:t>Sany Palfinger</a:t>
+                        <a:t>Palfinger</a:t>
                       </a:r>
                     </a:p>
                   </a:txBody>
@@ -7254,7 +7509,7 @@
                           </a:solidFill>
                           <a:latin typeface="Arial"/>
                         </a:rPr>
-                        <a:t>SPK61502</a:t>
+                        <a:t>PK 88002</a:t>
                       </a:r>
                     </a:p>
                   </a:txBody>
@@ -7300,7 +7555,7 @@
                           </a:solidFill>
                           <a:latin typeface="Arial"/>
                         </a:rPr>
-                        <a:t>57%</a:t>
+                        <a:t>100%</a:t>
                       </a:r>
                     </a:p>
                   </a:txBody>
@@ -7323,7 +7578,7 @@
                           </a:solidFill>
                           <a:latin typeface="Arial"/>
                         </a:rPr>
-                        <a:t>Rp 1.400.000.000</a:t>
+                        <a:t>Rp 2.220.000.000</a:t>
                       </a:r>
                     </a:p>
                   </a:txBody>
@@ -7346,7 +7601,7 @@
                           </a:solidFill>
                           <a:latin typeface="Arial"/>
                         </a:rPr>
-                        <a:t>Ferrari</a:t>
+                        <a:t>—</a:t>
                       </a:r>
                     </a:p>
                   </a:txBody>
@@ -7369,7 +7624,7 @@
                           </a:solidFill>
                           <a:latin typeface="Arial"/>
                         </a:rPr>
-                        <a:t>9661C</a:t>
+                        <a:t>—</a:t>
                       </a:r>
                     </a:p>
                   </a:txBody>
@@ -7392,7 +7647,7 @@
                           </a:solidFill>
                           <a:latin typeface="Arial"/>
                         </a:rPr>
-                        <a:t>Price not yet known</a:t>
+                        <a:t>No Ferrari model</a:t>
                       </a:r>
                     </a:p>
                   </a:txBody>
@@ -7403,517 +7658,7 @@
                   </a:tcPr>
                 </a:tc>
               </a:tr>
-              <a:tr h="352425">
-                <a:tc>
-                  <a:txBody>
-                    <a:bodyPr/>
-                    <a:lstStyle/>
-                    <a:p>
-                      <a:pPr algn="ctr"/>
-                      <a:r>
-                        <a:rPr sz="1100" b="1">
-                          <a:solidFill>
-                            <a:srgbClr val="11181C"/>
-                          </a:solidFill>
-                          <a:latin typeface="Arial"/>
-                        </a:rPr>
-                        <a:t>70 – 75</a:t>
-                      </a:r>
-                    </a:p>
-                  </a:txBody>
-                  <a:tcPr anchor="ctr" marL="38100" marR="38100" marT="9525" marB="9525">
-                    <a:solidFill>
-                      <a:srgbClr val="FFFFFF"/>
-                    </a:solidFill>
-                  </a:tcPr>
-                </a:tc>
-                <a:tc>
-                  <a:txBody>
-                    <a:bodyPr/>
-                    <a:lstStyle/>
-                    <a:p>
-                      <a:pPr algn="ctr"/>
-                      <a:r>
-                        <a:rPr sz="1100" b="0">
-                          <a:solidFill>
-                            <a:srgbClr val="11181C"/>
-                          </a:solidFill>
-                          <a:latin typeface="Arial"/>
-                        </a:rPr>
-                        <a:t>2</a:t>
-                      </a:r>
-                    </a:p>
-                  </a:txBody>
-                  <a:tcPr anchor="ctr" marL="38100" marR="38100" marT="9525" marB="9525">
-                    <a:solidFill>
-                      <a:srgbClr val="FFFFFF"/>
-                    </a:solidFill>
-                  </a:tcPr>
-                </a:tc>
-                <a:tc>
-                  <a:txBody>
-                    <a:bodyPr/>
-                    <a:lstStyle/>
-                    <a:p>
-                      <a:pPr algn="ctr"/>
-                      <a:r>
-                        <a:rPr sz="1100" b="0">
-                          <a:solidFill>
-                            <a:srgbClr val="11181C"/>
-                          </a:solidFill>
-                          <a:latin typeface="Arial"/>
-                        </a:rPr>
-                        <a:t>4%</a:t>
-                      </a:r>
-                    </a:p>
-                  </a:txBody>
-                  <a:tcPr anchor="ctr" marL="38100" marR="38100" marT="9525" marB="9525">
-                    <a:solidFill>
-                      <a:srgbClr val="FFFFFF"/>
-                    </a:solidFill>
-                  </a:tcPr>
-                </a:tc>
-                <a:tc>
-                  <a:txBody>
-                    <a:bodyPr/>
-                    <a:lstStyle/>
-                    <a:p>
-                      <a:pPr algn="ctr"/>
-                      <a:r>
-                        <a:rPr sz="1100" b="1">
-                          <a:solidFill>
-                            <a:srgbClr val="11181C"/>
-                          </a:solidFill>
-                          <a:latin typeface="Arial"/>
-                        </a:rPr>
-                        <a:t>Palfinger</a:t>
-                      </a:r>
-                    </a:p>
-                  </a:txBody>
-                  <a:tcPr anchor="ctr" marL="38100" marR="38100" marT="9525" marB="9525">
-                    <a:solidFill>
-                      <a:srgbClr val="FFFFFF"/>
-                    </a:solidFill>
-                  </a:tcPr>
-                </a:tc>
-                <a:tc>
-                  <a:txBody>
-                    <a:bodyPr/>
-                    <a:lstStyle/>
-                    <a:p>
-                      <a:pPr algn="ctr"/>
-                      <a:r>
-                        <a:rPr sz="1100" b="0">
-                          <a:solidFill>
-                            <a:srgbClr val="11181C"/>
-                          </a:solidFill>
-                          <a:latin typeface="Arial"/>
-                        </a:rPr>
-                        <a:t>PK 76002</a:t>
-                      </a:r>
-                    </a:p>
-                  </a:txBody>
-                  <a:tcPr anchor="ctr" marL="38100" marR="38100" marT="9525" marB="9525">
-                    <a:solidFill>
-                      <a:srgbClr val="FFFFFF"/>
-                    </a:solidFill>
-                  </a:tcPr>
-                </a:tc>
-                <a:tc>
-                  <a:txBody>
-                    <a:bodyPr/>
-                    <a:lstStyle/>
-                    <a:p>
-                      <a:pPr algn="ctr"/>
-                      <a:r>
-                        <a:rPr sz="1100" b="0">
-                          <a:solidFill>
-                            <a:srgbClr val="11181C"/>
-                          </a:solidFill>
-                          <a:latin typeface="Arial"/>
-                        </a:rPr>
-                        <a:t>2</a:t>
-                      </a:r>
-                    </a:p>
-                  </a:txBody>
-                  <a:tcPr anchor="ctr" marL="38100" marR="38100" marT="9525" marB="9525">
-                    <a:solidFill>
-                      <a:srgbClr val="FFFFFF"/>
-                    </a:solidFill>
-                  </a:tcPr>
-                </a:tc>
-                <a:tc>
-                  <a:txBody>
-                    <a:bodyPr/>
-                    <a:lstStyle/>
-                    <a:p>
-                      <a:pPr algn="ctr"/>
-                      <a:r>
-                        <a:rPr sz="1100" b="0">
-                          <a:solidFill>
-                            <a:srgbClr val="11181C"/>
-                          </a:solidFill>
-                          <a:latin typeface="Arial"/>
-                        </a:rPr>
-                        <a:t>100%</a:t>
-                      </a:r>
-                    </a:p>
-                  </a:txBody>
-                  <a:tcPr anchor="ctr" marL="38100" marR="38100" marT="9525" marB="9525">
-                    <a:solidFill>
-                      <a:srgbClr val="FFFFFF"/>
-                    </a:solidFill>
-                  </a:tcPr>
-                </a:tc>
-                <a:tc>
-                  <a:txBody>
-                    <a:bodyPr/>
-                    <a:lstStyle/>
-                    <a:p>
-                      <a:pPr algn="ctr"/>
-                      <a:r>
-                        <a:rPr sz="1100" b="0">
-                          <a:solidFill>
-                            <a:srgbClr val="11181C"/>
-                          </a:solidFill>
-                          <a:latin typeface="Arial"/>
-                        </a:rPr>
-                        <a:t>Rp 2.290.000.000</a:t>
-                      </a:r>
-                    </a:p>
-                  </a:txBody>
-                  <a:tcPr anchor="ctr" marL="38100" marR="38100" marT="9525" marB="9525">
-                    <a:solidFill>
-                      <a:srgbClr val="FFFFFF"/>
-                    </a:solidFill>
-                  </a:tcPr>
-                </a:tc>
-                <a:tc>
-                  <a:txBody>
-                    <a:bodyPr/>
-                    <a:lstStyle/>
-                    <a:p>
-                      <a:pPr algn="ctr"/>
-                      <a:r>
-                        <a:rPr sz="1100" b="1">
-                          <a:solidFill>
-                            <a:srgbClr val="11181C"/>
-                          </a:solidFill>
-                          <a:latin typeface="Arial"/>
-                        </a:rPr>
-                        <a:t>Ferrari</a:t>
-                      </a:r>
-                    </a:p>
-                  </a:txBody>
-                  <a:tcPr anchor="ctr" marL="38100" marR="38100" marT="9525" marB="9525">
-                    <a:solidFill>
-                      <a:srgbClr val="FEEBEC"/>
-                    </a:solidFill>
-                  </a:tcPr>
-                </a:tc>
-                <a:tc>
-                  <a:txBody>
-                    <a:bodyPr/>
-                    <a:lstStyle/>
-                    <a:p>
-                      <a:pPr algn="ctr"/>
-                      <a:r>
-                        <a:rPr sz="1100" b="0">
-                          <a:solidFill>
-                            <a:srgbClr val="11181C"/>
-                          </a:solidFill>
-                          <a:latin typeface="Arial"/>
-                        </a:rPr>
-                        <a:t>990R</a:t>
-                      </a:r>
-                    </a:p>
-                  </a:txBody>
-                  <a:tcPr anchor="ctr" marL="38100" marR="38100" marT="9525" marB="9525">
-                    <a:solidFill>
-                      <a:srgbClr val="FEEBEC"/>
-                    </a:solidFill>
-                  </a:tcPr>
-                </a:tc>
-                <a:tc>
-                  <a:txBody>
-                    <a:bodyPr/>
-                    <a:lstStyle/>
-                    <a:p>
-                      <a:pPr algn="ctr"/>
-                      <a:r>
-                        <a:rPr sz="1100" b="0">
-                          <a:solidFill>
-                            <a:srgbClr val="11181C"/>
-                          </a:solidFill>
-                          <a:latin typeface="Arial"/>
-                        </a:rPr>
-                        <a:t>Rp 4.110.000.000  (+79%)</a:t>
-                      </a:r>
-                    </a:p>
-                  </a:txBody>
-                  <a:tcPr anchor="ctr" marL="38100" marR="38100" marT="9525" marB="9525">
-                    <a:solidFill>
-                      <a:srgbClr val="FEEBEC"/>
-                    </a:solidFill>
-                  </a:tcPr>
-                </a:tc>
-              </a:tr>
-              <a:tr h="352425">
-                <a:tc>
-                  <a:txBody>
-                    <a:bodyPr/>
-                    <a:lstStyle/>
-                    <a:p>
-                      <a:pPr algn="ctr"/>
-                      <a:r>
-                        <a:rPr sz="1100" b="1">
-                          <a:solidFill>
-                            <a:srgbClr val="11181C"/>
-                          </a:solidFill>
-                          <a:latin typeface="Arial"/>
-                        </a:rPr>
-                        <a:t>80 – 85</a:t>
-                      </a:r>
-                    </a:p>
-                  </a:txBody>
-                  <a:tcPr anchor="ctr" marL="38100" marR="38100" marT="9525" marB="9525">
-                    <a:solidFill>
-                      <a:srgbClr val="FFFFFF"/>
-                    </a:solidFill>
-                  </a:tcPr>
-                </a:tc>
-                <a:tc>
-                  <a:txBody>
-                    <a:bodyPr/>
-                    <a:lstStyle/>
-                    <a:p>
-                      <a:pPr algn="ctr"/>
-                      <a:r>
-                        <a:rPr sz="1100" b="0">
-                          <a:solidFill>
-                            <a:srgbClr val="11181C"/>
-                          </a:solidFill>
-                          <a:latin typeface="Arial"/>
-                        </a:rPr>
-                        <a:t>1</a:t>
-                      </a:r>
-                    </a:p>
-                  </a:txBody>
-                  <a:tcPr anchor="ctr" marL="38100" marR="38100" marT="9525" marB="9525">
-                    <a:solidFill>
-                      <a:srgbClr val="FFFFFF"/>
-                    </a:solidFill>
-                  </a:tcPr>
-                </a:tc>
-                <a:tc>
-                  <a:txBody>
-                    <a:bodyPr/>
-                    <a:lstStyle/>
-                    <a:p>
-                      <a:pPr algn="ctr"/>
-                      <a:r>
-                        <a:rPr sz="1100" b="0">
-                          <a:solidFill>
-                            <a:srgbClr val="11181C"/>
-                          </a:solidFill>
-                          <a:latin typeface="Arial"/>
-                        </a:rPr>
-                        <a:t>2%</a:t>
-                      </a:r>
-                    </a:p>
-                  </a:txBody>
-                  <a:tcPr anchor="ctr" marL="38100" marR="38100" marT="9525" marB="9525">
-                    <a:solidFill>
-                      <a:srgbClr val="FFFFFF"/>
-                    </a:solidFill>
-                  </a:tcPr>
-                </a:tc>
-                <a:tc>
-                  <a:txBody>
-                    <a:bodyPr/>
-                    <a:lstStyle/>
-                    <a:p>
-                      <a:pPr algn="ctr"/>
-                      <a:r>
-                        <a:rPr sz="1100" b="1">
-                          <a:solidFill>
-                            <a:srgbClr val="11181C"/>
-                          </a:solidFill>
-                          <a:latin typeface="Arial"/>
-                        </a:rPr>
-                        <a:t>Palfinger</a:t>
-                      </a:r>
-                    </a:p>
-                  </a:txBody>
-                  <a:tcPr anchor="ctr" marL="38100" marR="38100" marT="9525" marB="9525">
-                    <a:solidFill>
-                      <a:srgbClr val="FFFFFF"/>
-                    </a:solidFill>
-                  </a:tcPr>
-                </a:tc>
-                <a:tc>
-                  <a:txBody>
-                    <a:bodyPr/>
-                    <a:lstStyle/>
-                    <a:p>
-                      <a:pPr algn="ctr"/>
-                      <a:r>
-                        <a:rPr sz="1100" b="0">
-                          <a:solidFill>
-                            <a:srgbClr val="11181C"/>
-                          </a:solidFill>
-                          <a:latin typeface="Arial"/>
-                        </a:rPr>
-                        <a:t>PK 88002</a:t>
-                      </a:r>
-                    </a:p>
-                  </a:txBody>
-                  <a:tcPr anchor="ctr" marL="38100" marR="38100" marT="9525" marB="9525">
-                    <a:solidFill>
-                      <a:srgbClr val="FFFFFF"/>
-                    </a:solidFill>
-                  </a:tcPr>
-                </a:tc>
-                <a:tc>
-                  <a:txBody>
-                    <a:bodyPr/>
-                    <a:lstStyle/>
-                    <a:p>
-                      <a:pPr algn="ctr"/>
-                      <a:r>
-                        <a:rPr sz="1100" b="0">
-                          <a:solidFill>
-                            <a:srgbClr val="11181C"/>
-                          </a:solidFill>
-                          <a:latin typeface="Arial"/>
-                        </a:rPr>
-                        <a:t>1</a:t>
-                      </a:r>
-                    </a:p>
-                  </a:txBody>
-                  <a:tcPr anchor="ctr" marL="38100" marR="38100" marT="9525" marB="9525">
-                    <a:solidFill>
-                      <a:srgbClr val="FFFFFF"/>
-                    </a:solidFill>
-                  </a:tcPr>
-                </a:tc>
-                <a:tc>
-                  <a:txBody>
-                    <a:bodyPr/>
-                    <a:lstStyle/>
-                    <a:p>
-                      <a:pPr algn="ctr"/>
-                      <a:r>
-                        <a:rPr sz="1100" b="0">
-                          <a:solidFill>
-                            <a:srgbClr val="11181C"/>
-                          </a:solidFill>
-                          <a:latin typeface="Arial"/>
-                        </a:rPr>
-                        <a:t>100%</a:t>
-                      </a:r>
-                    </a:p>
-                  </a:txBody>
-                  <a:tcPr anchor="ctr" marL="38100" marR="38100" marT="9525" marB="9525">
-                    <a:solidFill>
-                      <a:srgbClr val="FFFFFF"/>
-                    </a:solidFill>
-                  </a:tcPr>
-                </a:tc>
-                <a:tc>
-                  <a:txBody>
-                    <a:bodyPr/>
-                    <a:lstStyle/>
-                    <a:p>
-                      <a:pPr algn="ctr"/>
-                      <a:r>
-                        <a:rPr sz="1100" b="0">
-                          <a:solidFill>
-                            <a:srgbClr val="11181C"/>
-                          </a:solidFill>
-                          <a:latin typeface="Arial"/>
-                        </a:rPr>
-                        <a:t>Rp 2.220.000.000</a:t>
-                      </a:r>
-                    </a:p>
-                  </a:txBody>
-                  <a:tcPr anchor="ctr" marL="38100" marR="38100" marT="9525" marB="9525">
-                    <a:solidFill>
-                      <a:srgbClr val="FFFFFF"/>
-                    </a:solidFill>
-                  </a:tcPr>
-                </a:tc>
-                <a:tc>
-                  <a:txBody>
-                    <a:bodyPr/>
-                    <a:lstStyle/>
-                    <a:p>
-                      <a:pPr algn="ctr"/>
-                      <a:r>
-                        <a:rPr sz="1100" b="1">
-                          <a:solidFill>
-                            <a:srgbClr val="11181C"/>
-                          </a:solidFill>
-                          <a:latin typeface="Arial"/>
-                        </a:rPr>
-                        <a:t>—</a:t>
-                      </a:r>
-                    </a:p>
-                  </a:txBody>
-                  <a:tcPr anchor="ctr" marL="38100" marR="38100" marT="9525" marB="9525">
-                    <a:solidFill>
-                      <a:srgbClr val="F0F2F4"/>
-                    </a:solidFill>
-                  </a:tcPr>
-                </a:tc>
-                <a:tc>
-                  <a:txBody>
-                    <a:bodyPr/>
-                    <a:lstStyle/>
-                    <a:p>
-                      <a:pPr algn="ctr"/>
-                      <a:r>
-                        <a:rPr sz="1100" b="0">
-                          <a:solidFill>
-                            <a:srgbClr val="11181C"/>
-                          </a:solidFill>
-                          <a:latin typeface="Arial"/>
-                        </a:rPr>
-                        <a:t>—</a:t>
-                      </a:r>
-                    </a:p>
-                  </a:txBody>
-                  <a:tcPr anchor="ctr" marL="38100" marR="38100" marT="9525" marB="9525">
-                    <a:solidFill>
-                      <a:srgbClr val="F0F2F4"/>
-                    </a:solidFill>
-                  </a:tcPr>
-                </a:tc>
-                <a:tc>
-                  <a:txBody>
-                    <a:bodyPr/>
-                    <a:lstStyle/>
-                    <a:p>
-                      <a:pPr algn="ctr"/>
-                      <a:r>
-                        <a:rPr sz="1100" b="0">
-                          <a:solidFill>
-                            <a:srgbClr val="11181C"/>
-                          </a:solidFill>
-                          <a:latin typeface="Arial"/>
-                        </a:rPr>
-                        <a:t>No Ferrari model</a:t>
-                      </a:r>
-                    </a:p>
-                  </a:txBody>
-                  <a:tcPr anchor="ctr" marL="38100" marR="38100" marT="9525" marB="9525">
-                    <a:solidFill>
-                      <a:srgbClr val="F0F2F4"/>
-                    </a:solidFill>
-                  </a:tcPr>
-                </a:tc>
-              </a:tr>
-              <a:tr h="352425">
+              <a:tr h="409575">
                 <a:tc>
                   <a:txBody>
                     <a:bodyPr/>

</xml_diff>